<commit_message>
updated Week3 lectures 5 and 6
</commit_message>
<xml_diff>
--- a/lecture_slides/Week3_Lecture6_Transfer_Functions_PoleZero_091026_forClass.pptx
+++ b/lecture_slides/Week3_Lecture6_Transfer_Functions_PoleZero_091026_forClass.pptx
@@ -32,6 +32,7 @@
     <p:sldId id="281" r:id="rId26"/>
     <p:sldId id="277" r:id="rId27"/>
     <p:sldId id="278" r:id="rId28"/>
+    <p:sldId id="283" r:id="rId29"/>
   </p:sldIdLst>
   <p:sldSz cx="12192000" cy="6858000"/>
   <p:notesSz cx="6858000" cy="12192000"/>
@@ -297,7 +298,7 @@
           </a:prstGeom>
           <a:extLst>
             <a:ext uri="{C572A759-6A51-4108-AA02-DFA0A04FC94B}">
-              <ma14:wrappingTextBoxFlag xmlns="" xmlns:ma14="http://schemas.microsoft.com/office/mac/drawingml/2011/main" val="0"/>
+              <ma14:wrappingTextBoxFlag xmlns:ma14="http://schemas.microsoft.com/office/mac/drawingml/2011/main" xmlns="" val="0"/>
             </a:ext>
           </a:extLst>
         </p:spPr>
@@ -375,7 +376,7 @@
           </a:prstGeom>
           <a:extLst>
             <a:ext uri="{C572A759-6A51-4108-AA02-DFA0A04FC94B}">
-              <ma14:wrappingTextBoxFlag xmlns="" xmlns:ma14="http://schemas.microsoft.com/office/mac/drawingml/2011/main" val="0"/>
+              <ma14:wrappingTextBoxFlag xmlns:ma14="http://schemas.microsoft.com/office/mac/drawingml/2011/main" xmlns="" val="0"/>
             </a:ext>
           </a:extLst>
         </p:spPr>
@@ -2352,93 +2353,224 @@
           </a:p>
         </p:txBody>
       </p:sp>
-      <p:sp>
-        <p:nvSpPr>
-          <p:cNvPr id="9" name="TextBox 8"/>
-          <p:cNvSpPr txBox="1"/>
-          <p:nvPr/>
-        </p:nvSpPr>
-        <p:spPr>
-          <a:xfrm>
-            <a:off x="7726679" y="2286000"/>
-            <a:ext cx="3154680" cy="2286000"/>
-          </a:xfrm>
-          <a:prstGeom prst="rect">
-            <a:avLst/>
-          </a:prstGeom>
-          <a:noFill/>
-        </p:spPr>
-        <p:txBody>
-          <a:bodyPr wrap="square" lIns="73152" rIns="36576" anchor="t">
-            <a:spAutoFit/>
-          </a:bodyPr>
-          <a:lstStyle/>
-          <a:p>
-            <a:pPr>
-              <a:spcAft>
-                <a:spcPts val="500"/>
-              </a:spcAft>
-              <a:defRPr sz="1600">
-                <a:solidFill>
-                  <a:srgbClr val="17212B"/>
-                </a:solidFill>
-                <a:latin typeface="Aptos"/>
-              </a:defRPr>
-            </a:pPr>
-            <a:r>
-              <a:t>• At ω equal to the zero angle, e^{jω}=z₀.</a:t>
-            </a:r>
-          </a:p>
-          <a:p>
-            <a:pPr>
-              <a:spcAft>
-                <a:spcPts val="500"/>
-              </a:spcAft>
-              <a:defRPr sz="1600">
-                <a:solidFill>
-                  <a:srgbClr val="17212B"/>
-                </a:solidFill>
-                <a:latin typeface="Aptos"/>
-              </a:defRPr>
-            </a:pPr>
-            <a:r>
-              <a:t>• The zero distance is exactly 0.</a:t>
-            </a:r>
-          </a:p>
-          <a:p>
-            <a:pPr>
-              <a:spcAft>
-                <a:spcPts val="500"/>
-              </a:spcAft>
-              <a:defRPr sz="1600">
-                <a:solidFill>
-                  <a:srgbClr val="17212B"/>
-                </a:solidFill>
-                <a:latin typeface="Aptos"/>
-              </a:defRPr>
-            </a:pPr>
-            <a:r>
-              <a:t>• Product in the numerator becomes 0.</a:t>
-            </a:r>
-          </a:p>
-          <a:p>
-            <a:pPr>
-              <a:spcAft>
-                <a:spcPts val="500"/>
-              </a:spcAft>
-              <a:defRPr sz="1600">
-                <a:solidFill>
-                  <a:srgbClr val="17212B"/>
-                </a:solidFill>
-                <a:latin typeface="Aptos"/>
-              </a:defRPr>
-            </a:pPr>
-            <a:r>
-              <a:t>• Therefore |H|=0: a perfect notch.</a:t>
-            </a:r>
-          </a:p>
-        </p:txBody>
-      </p:sp>
+      <mc:AlternateContent xmlns:mc="http://schemas.openxmlformats.org/markup-compatibility/2006">
+        <mc:Choice xmlns:a14="http://schemas.microsoft.com/office/drawing/2010/main" Requires="a14">
+          <p:sp>
+            <p:nvSpPr>
+              <p:cNvPr id="9" name="TextBox 8"/>
+              <p:cNvSpPr txBox="1"/>
+              <p:nvPr/>
+            </p:nvSpPr>
+            <p:spPr>
+              <a:xfrm>
+                <a:off x="7726678" y="2286000"/>
+                <a:ext cx="3350031" cy="1770036"/>
+              </a:xfrm>
+              <a:prstGeom prst="rect">
+                <a:avLst/>
+              </a:prstGeom>
+              <a:noFill/>
+            </p:spPr>
+            <p:txBody>
+              <a:bodyPr wrap="square" lIns="73152" rIns="36576" anchor="t">
+                <a:spAutoFit/>
+              </a:bodyPr>
+              <a:lstStyle/>
+              <a:p>
+                <a:pPr>
+                  <a:spcAft>
+                    <a:spcPts val="500"/>
+                  </a:spcAft>
+                  <a:defRPr sz="1600">
+                    <a:solidFill>
+                      <a:srgbClr val="17212B"/>
+                    </a:solidFill>
+                    <a:latin typeface="Aptos"/>
+                  </a:defRPr>
+                </a:pPr>
+                <a:r>
+                  <a:rPr lang="en-US" dirty="0"/>
+                  <a:t>• At </a:t>
+                </a:r>
+                <a:r>
+                  <a:rPr lang="el-GR" dirty="0"/>
+                  <a:t>ω </a:t>
+                </a:r>
+                <a:r>
+                  <a:rPr lang="en-US" dirty="0"/>
+                  <a:t>equal to the zero angle, </a:t>
+                </a:r>
+                <a14:m>
+                  <m:oMath xmlns:m="http://schemas.openxmlformats.org/officeDocument/2006/math">
+                    <m:sSup>
+                      <m:sSupPr>
+                        <m:ctrlPr>
+                          <a:rPr lang="en-US" b="0" i="1" smtClean="0">
+                            <a:latin typeface="Cambria Math" panose="02040503050406030204" pitchFamily="18" charset="0"/>
+                          </a:rPr>
+                        </m:ctrlPr>
+                      </m:sSupPr>
+                      <m:e>
+                        <m:r>
+                          <a:rPr lang="en-US" b="0" i="1" smtClean="0">
+                            <a:latin typeface="Cambria Math" panose="02040503050406030204" pitchFamily="18" charset="0"/>
+                          </a:rPr>
+                          <m:t>𝑒</m:t>
+                        </m:r>
+                      </m:e>
+                      <m:sup>
+                        <m:r>
+                          <a:rPr lang="en-US" b="0" i="1" smtClean="0">
+                            <a:latin typeface="Cambria Math" panose="02040503050406030204" pitchFamily="18" charset="0"/>
+                          </a:rPr>
+                          <m:t>𝑗</m:t>
+                        </m:r>
+                        <m:r>
+                          <a:rPr lang="en-US" b="0" i="1" smtClean="0">
+                            <a:latin typeface="Cambria Math" panose="02040503050406030204" pitchFamily="18" charset="0"/>
+                            <a:ea typeface="Cambria Math" panose="02040503050406030204" pitchFamily="18" charset="0"/>
+                          </a:rPr>
+                          <m:t>𝜔</m:t>
+                        </m:r>
+                      </m:sup>
+                    </m:sSup>
+                    <m:r>
+                      <a:rPr lang="en-US" b="0" i="1" smtClean="0">
+                        <a:latin typeface="Cambria Math" panose="02040503050406030204" pitchFamily="18" charset="0"/>
+                        <a:ea typeface="Cambria Math" panose="02040503050406030204" pitchFamily="18" charset="0"/>
+                      </a:rPr>
+                      <m:t>=</m:t>
+                    </m:r>
+                    <m:sSub>
+                      <m:sSubPr>
+                        <m:ctrlPr>
+                          <a:rPr lang="en-US" b="0" i="1" smtClean="0">
+                            <a:latin typeface="Cambria Math" panose="02040503050406030204" pitchFamily="18" charset="0"/>
+                            <a:ea typeface="Cambria Math" panose="02040503050406030204" pitchFamily="18" charset="0"/>
+                          </a:rPr>
+                        </m:ctrlPr>
+                      </m:sSubPr>
+                      <m:e>
+                        <m:r>
+                          <a:rPr lang="en-US" b="0" i="1" smtClean="0">
+                            <a:latin typeface="Cambria Math" panose="02040503050406030204" pitchFamily="18" charset="0"/>
+                            <a:ea typeface="Cambria Math" panose="02040503050406030204" pitchFamily="18" charset="0"/>
+                          </a:rPr>
+                          <m:t>𝑧</m:t>
+                        </m:r>
+                      </m:e>
+                      <m:sub>
+                        <m:r>
+                          <a:rPr lang="en-US" b="0" i="1" smtClean="0">
+                            <a:latin typeface="Cambria Math" panose="02040503050406030204" pitchFamily="18" charset="0"/>
+                            <a:ea typeface="Cambria Math" panose="02040503050406030204" pitchFamily="18" charset="0"/>
+                          </a:rPr>
+                          <m:t>0</m:t>
+                        </m:r>
+                      </m:sub>
+                    </m:sSub>
+                  </m:oMath>
+                </a14:m>
+                <a:endParaRPr lang="ar-AE" dirty="0"/>
+              </a:p>
+              <a:p>
+                <a:pPr>
+                  <a:spcAft>
+                    <a:spcPts val="500"/>
+                  </a:spcAft>
+                  <a:defRPr sz="1600">
+                    <a:solidFill>
+                      <a:srgbClr val="17212B"/>
+                    </a:solidFill>
+                    <a:latin typeface="Aptos"/>
+                  </a:defRPr>
+                </a:pPr>
+                <a:r>
+                  <a:rPr lang="ar-AE" dirty="0"/>
+                  <a:t>• </a:t>
+                </a:r>
+                <a:r>
+                  <a:rPr lang="en-US" dirty="0"/>
+                  <a:t>The zero distance is exactly 0.</a:t>
+                </a:r>
+              </a:p>
+              <a:p>
+                <a:pPr>
+                  <a:spcAft>
+                    <a:spcPts val="500"/>
+                  </a:spcAft>
+                  <a:defRPr sz="1600">
+                    <a:solidFill>
+                      <a:srgbClr val="17212B"/>
+                    </a:solidFill>
+                    <a:latin typeface="Aptos"/>
+                  </a:defRPr>
+                </a:pPr>
+                <a:r>
+                  <a:rPr lang="en-US" dirty="0"/>
+                  <a:t>• Product in the numerator becomes 0.</a:t>
+                </a:r>
+              </a:p>
+              <a:p>
+                <a:pPr>
+                  <a:spcAft>
+                    <a:spcPts val="500"/>
+                  </a:spcAft>
+                  <a:defRPr sz="1600">
+                    <a:solidFill>
+                      <a:srgbClr val="17212B"/>
+                    </a:solidFill>
+                    <a:latin typeface="Aptos"/>
+                  </a:defRPr>
+                </a:pPr>
+                <a:r>
+                  <a:rPr lang="en-US" dirty="0"/>
+                  <a:t>• Therefore |H|=0: a perfect notch.</a:t>
+                </a:r>
+                <a:endParaRPr dirty="0"/>
+              </a:p>
+            </p:txBody>
+          </p:sp>
+        </mc:Choice>
+        <mc:Fallback>
+          <p:sp>
+            <p:nvSpPr>
+              <p:cNvPr id="9" name="TextBox 8"/>
+              <p:cNvSpPr txBox="1">
+                <a:spLocks noRot="1" noChangeAspect="1" noMove="1" noResize="1" noEditPoints="1" noAdjustHandles="1" noChangeArrowheads="1" noChangeShapeType="1" noTextEdit="1"/>
+              </p:cNvSpPr>
+              <p:nvPr/>
+            </p:nvSpPr>
+            <p:spPr>
+              <a:xfrm>
+                <a:off x="7726678" y="2286000"/>
+                <a:ext cx="3350031" cy="1770036"/>
+              </a:xfrm>
+              <a:prstGeom prst="rect">
+                <a:avLst/>
+              </a:prstGeom>
+              <a:blipFill>
+                <a:blip r:embed="rId3"/>
+                <a:stretch>
+                  <a:fillRect l="-1636" t="-690" r="-2000" b="-3448"/>
+                </a:stretch>
+              </a:blipFill>
+            </p:spPr>
+            <p:txBody>
+              <a:bodyPr/>
+              <a:lstStyle/>
+              <a:p>
+                <a:r>
+                  <a:rPr lang="en-US">
+                    <a:noFill/>
+                  </a:rPr>
+                  <a:t> </a:t>
+                </a:r>
+              </a:p>
+            </p:txBody>
+          </p:sp>
+        </mc:Fallback>
+      </mc:AlternateContent>
       <p:sp>
         <p:nvSpPr>
           <p:cNvPr id="10" name="TextBox 9"/>
@@ -3667,77 +3799,266 @@
           </a:p>
         </p:txBody>
       </p:sp>
-      <p:sp>
-        <p:nvSpPr>
-          <p:cNvPr id="10" name="TextBox 9"/>
-          <p:cNvSpPr txBox="1"/>
-          <p:nvPr/>
-        </p:nvSpPr>
-        <p:spPr>
-          <a:xfrm>
-            <a:off x="8138160" y="3108960"/>
-            <a:ext cx="2971800" cy="1645920"/>
-          </a:xfrm>
-          <a:prstGeom prst="rect">
-            <a:avLst/>
-          </a:prstGeom>
-          <a:noFill/>
-        </p:spPr>
-        <p:txBody>
-          <a:bodyPr wrap="square" lIns="73152" rIns="36576" anchor="t">
-            <a:spAutoFit/>
-          </a:bodyPr>
-          <a:lstStyle/>
-          <a:p>
-            <a:pPr>
-              <a:spcAft>
-                <a:spcPts val="500"/>
-              </a:spcAft>
-              <a:defRPr sz="1500">
-                <a:solidFill>
-                  <a:srgbClr val="17212B"/>
-                </a:solidFill>
-                <a:latin typeface="Aptos"/>
-              </a:defRPr>
-            </a:pPr>
-            <a:r>
-              <a:t>• Zeros: e^{±jω₀}</a:t>
-            </a:r>
-          </a:p>
-          <a:p>
-            <a:pPr>
-              <a:spcAft>
-                <a:spcPts val="500"/>
-              </a:spcAft>
-              <a:defRPr sz="1500">
-                <a:solidFill>
-                  <a:srgbClr val="17212B"/>
-                </a:solidFill>
-                <a:latin typeface="Aptos"/>
-              </a:defRPr>
-            </a:pPr>
-            <a:r>
-              <a:t>• Nearby poles at r e^{±jω₀} make a narrow, well-behaved notch.</a:t>
-            </a:r>
-          </a:p>
-          <a:p>
-            <a:pPr>
-              <a:spcAft>
-                <a:spcPts val="500"/>
-              </a:spcAft>
-              <a:defRPr sz="1500">
-                <a:solidFill>
-                  <a:srgbClr val="17212B"/>
-                </a:solidFill>
-                <a:latin typeface="Aptos"/>
-              </a:defRPr>
-            </a:pPr>
-            <a:r>
-              <a:t>• Choose r&lt;1 for causal stability.</a:t>
-            </a:r>
-          </a:p>
-        </p:txBody>
-      </p:sp>
+      <mc:AlternateContent xmlns:mc="http://schemas.openxmlformats.org/markup-compatibility/2006">
+        <mc:Choice xmlns:a14="http://schemas.microsoft.com/office/drawing/2010/main" Requires="a14">
+          <p:sp>
+            <p:nvSpPr>
+              <p:cNvPr id="10" name="TextBox 9"/>
+              <p:cNvSpPr txBox="1"/>
+              <p:nvPr/>
+            </p:nvSpPr>
+            <p:spPr>
+              <a:xfrm>
+                <a:off x="8138160" y="3108960"/>
+                <a:ext cx="2971800" cy="1158907"/>
+              </a:xfrm>
+              <a:prstGeom prst="rect">
+                <a:avLst/>
+              </a:prstGeom>
+              <a:noFill/>
+            </p:spPr>
+            <p:txBody>
+              <a:bodyPr wrap="square" lIns="73152" rIns="36576" anchor="t">
+                <a:spAutoFit/>
+              </a:bodyPr>
+              <a:lstStyle/>
+              <a:p>
+                <a:pPr>
+                  <a:spcAft>
+                    <a:spcPts val="500"/>
+                  </a:spcAft>
+                  <a:defRPr sz="1500">
+                    <a:solidFill>
+                      <a:srgbClr val="17212B"/>
+                    </a:solidFill>
+                    <a:latin typeface="Aptos"/>
+                  </a:defRPr>
+                </a:pPr>
+                <a:r>
+                  <a:rPr lang="en-US" dirty="0"/>
+                  <a:t>• Zeros: </a:t>
+                </a:r>
+                <a14:m>
+                  <m:oMath xmlns:m="http://schemas.openxmlformats.org/officeDocument/2006/math">
+                    <m:sSup>
+                      <m:sSupPr>
+                        <m:ctrlPr>
+                          <a:rPr lang="en-US" b="0" i="1" dirty="0" smtClean="0">
+                            <a:latin typeface="Cambria Math" panose="02040503050406030204" pitchFamily="18" charset="0"/>
+                          </a:rPr>
+                        </m:ctrlPr>
+                      </m:sSupPr>
+                      <m:e>
+                        <m:r>
+                          <a:rPr lang="en-US" b="0" i="1" dirty="0" smtClean="0">
+                            <a:latin typeface="Cambria Math" panose="02040503050406030204" pitchFamily="18" charset="0"/>
+                          </a:rPr>
+                          <m:t>𝑒</m:t>
+                        </m:r>
+                      </m:e>
+                      <m:sup>
+                        <m:r>
+                          <a:rPr lang="en-US" b="0" i="1" dirty="0" smtClean="0">
+                            <a:latin typeface="Cambria Math" panose="02040503050406030204" pitchFamily="18" charset="0"/>
+                            <a:ea typeface="Cambria Math" panose="02040503050406030204" pitchFamily="18" charset="0"/>
+                          </a:rPr>
+                          <m:t>±</m:t>
+                        </m:r>
+                        <m:r>
+                          <a:rPr lang="en-US" b="0" i="1" dirty="0" smtClean="0">
+                            <a:latin typeface="Cambria Math" panose="02040503050406030204" pitchFamily="18" charset="0"/>
+                          </a:rPr>
+                          <m:t>𝑗</m:t>
+                        </m:r>
+                        <m:sSub>
+                          <m:sSubPr>
+                            <m:ctrlPr>
+                              <a:rPr lang="en-US" b="0" i="1" dirty="0" smtClean="0">
+                                <a:latin typeface="Cambria Math" panose="02040503050406030204" pitchFamily="18" charset="0"/>
+                                <a:ea typeface="Cambria Math" panose="02040503050406030204" pitchFamily="18" charset="0"/>
+                              </a:rPr>
+                            </m:ctrlPr>
+                          </m:sSubPr>
+                          <m:e>
+                            <m:r>
+                              <a:rPr lang="en-US" b="0" i="1" dirty="0" smtClean="0">
+                                <a:latin typeface="Cambria Math" panose="02040503050406030204" pitchFamily="18" charset="0"/>
+                                <a:ea typeface="Cambria Math" panose="02040503050406030204" pitchFamily="18" charset="0"/>
+                              </a:rPr>
+                              <m:t>𝜔</m:t>
+                            </m:r>
+                          </m:e>
+                          <m:sub>
+                            <m:r>
+                              <a:rPr lang="en-US" b="0" i="1" dirty="0" smtClean="0">
+                                <a:latin typeface="Cambria Math" panose="02040503050406030204" pitchFamily="18" charset="0"/>
+                                <a:ea typeface="Cambria Math" panose="02040503050406030204" pitchFamily="18" charset="0"/>
+                              </a:rPr>
+                              <m:t>0</m:t>
+                            </m:r>
+                          </m:sub>
+                        </m:sSub>
+                      </m:sup>
+                    </m:sSup>
+                  </m:oMath>
+                </a14:m>
+                <a:endParaRPr lang="ar-AE" dirty="0"/>
+              </a:p>
+              <a:p>
+                <a:pPr>
+                  <a:spcAft>
+                    <a:spcPts val="500"/>
+                  </a:spcAft>
+                  <a:defRPr sz="1500">
+                    <a:solidFill>
+                      <a:srgbClr val="17212B"/>
+                    </a:solidFill>
+                    <a:latin typeface="Aptos"/>
+                  </a:defRPr>
+                </a:pPr>
+                <a:r>
+                  <a:rPr lang="ar-AE" dirty="0"/>
+                  <a:t>• </a:t>
+                </a:r>
+                <a:r>
+                  <a:rPr lang="en-US" dirty="0"/>
+                  <a:t>Nearby poles at </a:t>
+                </a:r>
+                <a14:m>
+                  <m:oMath xmlns:m="http://schemas.openxmlformats.org/officeDocument/2006/math">
+                    <m:r>
+                      <a:rPr lang="en-US" b="0" i="1" smtClean="0">
+                        <a:latin typeface="Cambria Math" panose="02040503050406030204" pitchFamily="18" charset="0"/>
+                      </a:rPr>
+                      <m:t>𝑟</m:t>
+                    </m:r>
+                    <m:sSup>
+                      <m:sSupPr>
+                        <m:ctrlPr>
+                          <a:rPr lang="en-US" b="0" i="1" smtClean="0">
+                            <a:latin typeface="Cambria Math" panose="02040503050406030204" pitchFamily="18" charset="0"/>
+                          </a:rPr>
+                        </m:ctrlPr>
+                      </m:sSupPr>
+                      <m:e>
+                        <m:r>
+                          <a:rPr lang="en-US" b="0" i="1" smtClean="0">
+                            <a:latin typeface="Cambria Math" panose="02040503050406030204" pitchFamily="18" charset="0"/>
+                          </a:rPr>
+                          <m:t>𝑒</m:t>
+                        </m:r>
+                      </m:e>
+                      <m:sup>
+                        <m:r>
+                          <a:rPr lang="en-US" b="0" i="1" smtClean="0">
+                            <a:latin typeface="Cambria Math" panose="02040503050406030204" pitchFamily="18" charset="0"/>
+                            <a:ea typeface="Cambria Math" panose="02040503050406030204" pitchFamily="18" charset="0"/>
+                          </a:rPr>
+                          <m:t>±</m:t>
+                        </m:r>
+                        <m:r>
+                          <a:rPr lang="en-US" b="0" i="1" smtClean="0">
+                            <a:latin typeface="Cambria Math" panose="02040503050406030204" pitchFamily="18" charset="0"/>
+                          </a:rPr>
+                          <m:t>𝑗</m:t>
+                        </m:r>
+                        <m:sSub>
+                          <m:sSubPr>
+                            <m:ctrlPr>
+                              <a:rPr lang="en-US" b="0" i="1" smtClean="0">
+                                <a:latin typeface="Cambria Math" panose="02040503050406030204" pitchFamily="18" charset="0"/>
+                                <a:ea typeface="Cambria Math" panose="02040503050406030204" pitchFamily="18" charset="0"/>
+                              </a:rPr>
+                            </m:ctrlPr>
+                          </m:sSubPr>
+                          <m:e>
+                            <m:r>
+                              <a:rPr lang="en-US" b="0" i="1" smtClean="0">
+                                <a:latin typeface="Cambria Math" panose="02040503050406030204" pitchFamily="18" charset="0"/>
+                                <a:ea typeface="Cambria Math" panose="02040503050406030204" pitchFamily="18" charset="0"/>
+                              </a:rPr>
+                              <m:t>𝜔</m:t>
+                            </m:r>
+                          </m:e>
+                          <m:sub>
+                            <m:r>
+                              <a:rPr lang="en-US" b="0" i="1" smtClean="0">
+                                <a:latin typeface="Cambria Math" panose="02040503050406030204" pitchFamily="18" charset="0"/>
+                                <a:ea typeface="Cambria Math" panose="02040503050406030204" pitchFamily="18" charset="0"/>
+                              </a:rPr>
+                              <m:t>0</m:t>
+                            </m:r>
+                          </m:sub>
+                        </m:sSub>
+                      </m:sup>
+                    </m:sSup>
+                  </m:oMath>
+                </a14:m>
+                <a:r>
+                  <a:rPr lang="en-US" dirty="0"/>
+                  <a:t> make a narrow, well-behaved notch.</a:t>
+                </a:r>
+              </a:p>
+              <a:p>
+                <a:pPr>
+                  <a:spcAft>
+                    <a:spcPts val="500"/>
+                  </a:spcAft>
+                  <a:defRPr sz="1500">
+                    <a:solidFill>
+                      <a:srgbClr val="17212B"/>
+                    </a:solidFill>
+                    <a:latin typeface="Aptos"/>
+                  </a:defRPr>
+                </a:pPr>
+                <a:r>
+                  <a:rPr lang="en-US" dirty="0"/>
+                  <a:t>• Choose r&lt;1 for causal stability.</a:t>
+                </a:r>
+                <a:endParaRPr dirty="0"/>
+              </a:p>
+            </p:txBody>
+          </p:sp>
+        </mc:Choice>
+        <mc:Fallback>
+          <p:sp>
+            <p:nvSpPr>
+              <p:cNvPr id="10" name="TextBox 9"/>
+              <p:cNvSpPr txBox="1">
+                <a:spLocks noRot="1" noChangeAspect="1" noMove="1" noResize="1" noEditPoints="1" noAdjustHandles="1" noChangeArrowheads="1" noChangeShapeType="1" noTextEdit="1"/>
+              </p:cNvSpPr>
+              <p:nvPr/>
+            </p:nvSpPr>
+            <p:spPr>
+              <a:xfrm>
+                <a:off x="8138160" y="3108960"/>
+                <a:ext cx="2971800" cy="1158907"/>
+              </a:xfrm>
+              <a:prstGeom prst="rect">
+                <a:avLst/>
+              </a:prstGeom>
+              <a:blipFill>
+                <a:blip r:embed="rId3"/>
+                <a:stretch>
+                  <a:fillRect l="-1639" b="-5263"/>
+                </a:stretch>
+              </a:blipFill>
+            </p:spPr>
+            <p:txBody>
+              <a:bodyPr/>
+              <a:lstStyle/>
+              <a:p>
+                <a:r>
+                  <a:rPr lang="en-US">
+                    <a:noFill/>
+                  </a:rPr>
+                  <a:t> </a:t>
+                </a:r>
+              </a:p>
+            </p:txBody>
+          </p:sp>
+        </mc:Fallback>
+      </mc:AlternateContent>
       <p:sp>
         <p:nvSpPr>
           <p:cNvPr id="11" name="TextBox 10"/>
@@ -10373,41 +10694,163 @@
           </a:p>
         </p:txBody>
       </p:sp>
-      <p:sp>
-        <p:nvSpPr>
-          <p:cNvPr id="20" name="TextBox 19"/>
-          <p:cNvSpPr txBox="1"/>
-          <p:nvPr/>
-        </p:nvSpPr>
-        <p:spPr>
-          <a:xfrm>
-            <a:off x="7607808" y="2578608"/>
-            <a:ext cx="1645920" cy="530352"/>
-          </a:xfrm>
-          <a:prstGeom prst="rect">
-            <a:avLst/>
-          </a:prstGeom>
-          <a:noFill/>
-        </p:spPr>
-        <p:txBody>
-          <a:bodyPr wrap="square" lIns="45720" rIns="45720" anchor="ctr">
-            <a:spAutoFit/>
-          </a:bodyPr>
-          <a:lstStyle/>
-          <a:p>
-            <a:pPr algn="ctr"/>
-            <a:r>
-              <a:rPr sz="1600" b="1">
-                <a:solidFill>
-                  <a:srgbClr val="16324F"/>
-                </a:solidFill>
-                <a:latin typeface="Aptos"/>
-              </a:rPr>
-              <a:t>stability + H(e^{jω})</a:t>
-            </a:r>
-          </a:p>
-        </p:txBody>
-      </p:sp>
+      <mc:AlternateContent xmlns:mc="http://schemas.openxmlformats.org/markup-compatibility/2006">
+        <mc:Choice xmlns:a14="http://schemas.microsoft.com/office/drawing/2010/main" Requires="a14">
+          <p:sp>
+            <p:nvSpPr>
+              <p:cNvPr id="20" name="TextBox 19"/>
+              <p:cNvSpPr txBox="1"/>
+              <p:nvPr/>
+            </p:nvSpPr>
+            <p:spPr>
+              <a:xfrm>
+                <a:off x="7607808" y="2548223"/>
+                <a:ext cx="1645920" cy="591124"/>
+              </a:xfrm>
+              <a:prstGeom prst="rect">
+                <a:avLst/>
+              </a:prstGeom>
+              <a:noFill/>
+            </p:spPr>
+            <p:txBody>
+              <a:bodyPr wrap="square" lIns="45720" rIns="45720" anchor="ctr">
+                <a:spAutoFit/>
+              </a:bodyPr>
+              <a:lstStyle/>
+              <a:p>
+                <a:pPr algn="ctr"/>
+                <a:r>
+                  <a:rPr lang="en-US" sz="1600" b="1" dirty="0">
+                    <a:solidFill>
+                      <a:srgbClr val="16324F"/>
+                    </a:solidFill>
+                    <a:latin typeface="Aptos"/>
+                  </a:rPr>
+                  <a:t>stability + </a:t>
+                </a:r>
+                <a14:m>
+                  <m:oMath xmlns:m="http://schemas.openxmlformats.org/officeDocument/2006/math">
+                    <m:r>
+                      <a:rPr lang="en-US" sz="1600" b="1" i="1" dirty="0" smtClean="0">
+                        <a:solidFill>
+                          <a:srgbClr val="16324F"/>
+                        </a:solidFill>
+                        <a:latin typeface="Cambria Math" panose="02040503050406030204" pitchFamily="18" charset="0"/>
+                      </a:rPr>
+                      <m:t>𝑯</m:t>
+                    </m:r>
+                    <m:r>
+                      <a:rPr lang="en-US" sz="1600" b="1" i="1" dirty="0" smtClean="0">
+                        <a:solidFill>
+                          <a:srgbClr val="16324F"/>
+                        </a:solidFill>
+                        <a:latin typeface="Cambria Math" panose="02040503050406030204" pitchFamily="18" charset="0"/>
+                      </a:rPr>
+                      <m:t>(</m:t>
+                    </m:r>
+                    <m:sSup>
+                      <m:sSupPr>
+                        <m:ctrlPr>
+                          <a:rPr lang="ar-AE" sz="1600" b="1" i="1" dirty="0" err="1">
+                            <a:solidFill>
+                              <a:srgbClr val="16324F"/>
+                            </a:solidFill>
+                            <a:latin typeface="Cambria Math" panose="02040503050406030204" pitchFamily="18" charset="0"/>
+                          </a:rPr>
+                        </m:ctrlPr>
+                      </m:sSupPr>
+                      <m:e>
+                        <m:r>
+                          <a:rPr lang="ar-AE" sz="1600" b="1" i="1" dirty="0" err="1">
+                            <a:solidFill>
+                              <a:srgbClr val="16324F"/>
+                            </a:solidFill>
+                            <a:latin typeface="Cambria Math" panose="02040503050406030204" pitchFamily="18" charset="0"/>
+                          </a:rPr>
+                          <m:t>𝒆</m:t>
+                        </m:r>
+                      </m:e>
+                      <m:sup>
+                        <m:r>
+                          <a:rPr lang="ar-AE" sz="1600" b="1" i="1" dirty="0" err="1" smtClean="0">
+                            <a:solidFill>
+                              <a:srgbClr val="16324F"/>
+                            </a:solidFill>
+                            <a:latin typeface="Cambria Math" panose="02040503050406030204" pitchFamily="18" charset="0"/>
+                          </a:rPr>
+                          <m:t>𝒋</m:t>
+                        </m:r>
+                        <m:r>
+                          <a:rPr lang="ar-AE" sz="1600" b="1" i="1" dirty="0" err="1" smtClean="0">
+                            <a:solidFill>
+                              <a:srgbClr val="16324F"/>
+                            </a:solidFill>
+                            <a:latin typeface="Cambria Math" panose="02040503050406030204" pitchFamily="18" charset="0"/>
+                          </a:rPr>
+                          <m:t>𝝎</m:t>
+                        </m:r>
+                      </m:sup>
+                    </m:sSup>
+                    <m:r>
+                      <a:rPr lang="ar-AE" sz="1600" b="1" i="1" dirty="0" smtClean="0">
+                        <a:solidFill>
+                          <a:srgbClr val="16324F"/>
+                        </a:solidFill>
+                        <a:latin typeface="Cambria Math" panose="02040503050406030204" pitchFamily="18" charset="0"/>
+                      </a:rPr>
+                      <m:t>)</m:t>
+                    </m:r>
+                  </m:oMath>
+                </a14:m>
+                <a:endParaRPr sz="1600" b="1" dirty="0">
+                  <a:solidFill>
+                    <a:srgbClr val="16324F"/>
+                  </a:solidFill>
+                  <a:latin typeface="Aptos"/>
+                </a:endParaRPr>
+              </a:p>
+            </p:txBody>
+          </p:sp>
+        </mc:Choice>
+        <mc:Fallback>
+          <p:sp>
+            <p:nvSpPr>
+              <p:cNvPr id="20" name="TextBox 19"/>
+              <p:cNvSpPr txBox="1">
+                <a:spLocks noRot="1" noChangeAspect="1" noMove="1" noResize="1" noEditPoints="1" noAdjustHandles="1" noChangeArrowheads="1" noChangeShapeType="1" noTextEdit="1"/>
+              </p:cNvSpPr>
+              <p:nvPr/>
+            </p:nvSpPr>
+            <p:spPr>
+              <a:xfrm>
+                <a:off x="7607808" y="2548223"/>
+                <a:ext cx="1645920" cy="591124"/>
+              </a:xfrm>
+              <a:prstGeom prst="rect">
+                <a:avLst/>
+              </a:prstGeom>
+              <a:blipFill>
+                <a:blip r:embed="rId2"/>
+                <a:stretch>
+                  <a:fillRect t="-3093" b="-5155"/>
+                </a:stretch>
+              </a:blipFill>
+            </p:spPr>
+            <p:txBody>
+              <a:bodyPr/>
+              <a:lstStyle/>
+              <a:p>
+                <a:r>
+                  <a:rPr lang="en-US">
+                    <a:noFill/>
+                  </a:rPr>
+                  <a:t> </a:t>
+                </a:r>
+              </a:p>
+            </p:txBody>
+          </p:sp>
+        </mc:Fallback>
+      </mc:AlternateContent>
       <p:cxnSp>
         <p:nvCxnSpPr>
           <p:cNvPr id="21" name="Connector 20"/>
@@ -11534,47 +11977,175 @@
           </a:p>
         </p:txBody>
       </p:sp>
-      <p:sp>
-        <p:nvSpPr>
-          <p:cNvPr id="20" name="TextBox 19">
-            <a:extLst>
-              <a:ext uri="{FF2B5EF4-FFF2-40B4-BE49-F238E27FC236}">
-                <a16:creationId xmlns:a16="http://schemas.microsoft.com/office/drawing/2014/main" id="{A077022D-37CD-BBB7-A7A5-54275E5758CC}"/>
-              </a:ext>
-            </a:extLst>
-          </p:cNvPr>
-          <p:cNvSpPr txBox="1"/>
-          <p:nvPr/>
-        </p:nvSpPr>
-        <p:spPr>
-          <a:xfrm>
-            <a:off x="7607808" y="2578608"/>
-            <a:ext cx="1645920" cy="530352"/>
-          </a:xfrm>
-          <a:prstGeom prst="rect">
-            <a:avLst/>
-          </a:prstGeom>
-          <a:noFill/>
-        </p:spPr>
-        <p:txBody>
-          <a:bodyPr wrap="square" lIns="45720" rIns="45720" anchor="ctr">
-            <a:spAutoFit/>
-          </a:bodyPr>
-          <a:lstStyle/>
-          <a:p>
-            <a:pPr algn="ctr"/>
-            <a:r>
-              <a:rPr sz="1600" b="1">
-                <a:solidFill>
-                  <a:srgbClr val="16324F"/>
-                </a:solidFill>
-                <a:latin typeface="Aptos"/>
-              </a:rPr>
-              <a:t>stability + H(e^{jω})</a:t>
-            </a:r>
-          </a:p>
-        </p:txBody>
-      </p:sp>
+      <mc:AlternateContent xmlns:mc="http://schemas.openxmlformats.org/markup-compatibility/2006">
+        <mc:Choice xmlns:a14="http://schemas.microsoft.com/office/drawing/2010/main" Requires="a14">
+          <p:sp>
+            <p:nvSpPr>
+              <p:cNvPr id="20" name="TextBox 19">
+                <a:extLst>
+                  <a:ext uri="{FF2B5EF4-FFF2-40B4-BE49-F238E27FC236}">
+                    <a16:creationId xmlns:a16="http://schemas.microsoft.com/office/drawing/2014/main" id="{A077022D-37CD-BBB7-A7A5-54275E5758CC}"/>
+                  </a:ext>
+                </a:extLst>
+              </p:cNvPr>
+              <p:cNvSpPr txBox="1"/>
+              <p:nvPr/>
+            </p:nvSpPr>
+            <p:spPr>
+              <a:xfrm>
+                <a:off x="7607808" y="2548223"/>
+                <a:ext cx="1645920" cy="591124"/>
+              </a:xfrm>
+              <a:prstGeom prst="rect">
+                <a:avLst/>
+              </a:prstGeom>
+              <a:noFill/>
+            </p:spPr>
+            <p:txBody>
+              <a:bodyPr wrap="square" lIns="45720" rIns="45720" anchor="ctr">
+                <a:spAutoFit/>
+              </a:bodyPr>
+              <a:lstStyle/>
+              <a:p>
+                <a:pPr algn="ctr"/>
+                <a:r>
+                  <a:rPr lang="en-US" sz="1600" b="1" dirty="0">
+                    <a:solidFill>
+                      <a:srgbClr val="16324F"/>
+                    </a:solidFill>
+                    <a:latin typeface="Aptos"/>
+                  </a:rPr>
+                  <a:t>stability + </a:t>
+                </a:r>
+                <a14:m>
+                  <m:oMath xmlns:m="http://schemas.openxmlformats.org/officeDocument/2006/math">
+                    <m:r>
+                      <a:rPr lang="en-US" sz="1600" b="1" i="1" dirty="0" smtClean="0">
+                        <a:solidFill>
+                          <a:srgbClr val="16324F"/>
+                        </a:solidFill>
+                        <a:latin typeface="Cambria Math" panose="02040503050406030204" pitchFamily="18" charset="0"/>
+                      </a:rPr>
+                      <m:t>𝑯</m:t>
+                    </m:r>
+                    <m:r>
+                      <a:rPr lang="en-US" sz="1600" b="1" i="1" dirty="0" smtClean="0">
+                        <a:solidFill>
+                          <a:srgbClr val="16324F"/>
+                        </a:solidFill>
+                        <a:latin typeface="Cambria Math" panose="02040503050406030204" pitchFamily="18" charset="0"/>
+                      </a:rPr>
+                      <m:t>(</m:t>
+                    </m:r>
+                    <m:sSup>
+                      <m:sSupPr>
+                        <m:ctrlPr>
+                          <a:rPr lang="ar-AE" sz="1600" b="1" i="1" dirty="0" err="1">
+                            <a:solidFill>
+                              <a:srgbClr val="16324F"/>
+                            </a:solidFill>
+                            <a:latin typeface="Cambria Math" panose="02040503050406030204" pitchFamily="18" charset="0"/>
+                          </a:rPr>
+                        </m:ctrlPr>
+                      </m:sSupPr>
+                      <m:e>
+                        <m:r>
+                          <a:rPr lang="ar-AE" sz="1600" b="1" i="1" dirty="0" err="1">
+                            <a:solidFill>
+                              <a:srgbClr val="16324F"/>
+                            </a:solidFill>
+                            <a:latin typeface="Cambria Math" panose="02040503050406030204" pitchFamily="18" charset="0"/>
+                          </a:rPr>
+                          <m:t>𝒆</m:t>
+                        </m:r>
+                      </m:e>
+                      <m:sup>
+                        <m:r>
+                          <a:rPr lang="ar-AE" sz="1600" b="1" i="1" dirty="0" err="1" smtClean="0">
+                            <a:solidFill>
+                              <a:srgbClr val="16324F"/>
+                            </a:solidFill>
+                            <a:latin typeface="Cambria Math" panose="02040503050406030204" pitchFamily="18" charset="0"/>
+                          </a:rPr>
+                          <m:t>𝒋</m:t>
+                        </m:r>
+                        <m:r>
+                          <a:rPr lang="ar-AE" sz="1600" b="1" i="1" dirty="0" err="1" smtClean="0">
+                            <a:solidFill>
+                              <a:srgbClr val="16324F"/>
+                            </a:solidFill>
+                            <a:latin typeface="Cambria Math" panose="02040503050406030204" pitchFamily="18" charset="0"/>
+                          </a:rPr>
+                          <m:t>𝝎</m:t>
+                        </m:r>
+                      </m:sup>
+                    </m:sSup>
+                    <m:r>
+                      <a:rPr lang="ar-AE" sz="1600" b="1" i="1" dirty="0" smtClean="0">
+                        <a:solidFill>
+                          <a:srgbClr val="16324F"/>
+                        </a:solidFill>
+                        <a:latin typeface="Cambria Math" panose="02040503050406030204" pitchFamily="18" charset="0"/>
+                      </a:rPr>
+                      <m:t>)</m:t>
+                    </m:r>
+                  </m:oMath>
+                </a14:m>
+                <a:endParaRPr sz="1600" b="1" dirty="0">
+                  <a:solidFill>
+                    <a:srgbClr val="16324F"/>
+                  </a:solidFill>
+                  <a:latin typeface="Aptos"/>
+                </a:endParaRPr>
+              </a:p>
+            </p:txBody>
+          </p:sp>
+        </mc:Choice>
+        <mc:Fallback>
+          <p:sp>
+            <p:nvSpPr>
+              <p:cNvPr id="20" name="TextBox 19">
+                <a:extLst>
+                  <a:ext uri="{FF2B5EF4-FFF2-40B4-BE49-F238E27FC236}">
+                    <a16:creationId xmlns:a16="http://schemas.microsoft.com/office/drawing/2014/main" id="{A077022D-37CD-BBB7-A7A5-54275E5758CC}"/>
+                  </a:ext>
+                </a:extLst>
+              </p:cNvPr>
+              <p:cNvSpPr txBox="1">
+                <a:spLocks noRot="1" noChangeAspect="1" noMove="1" noResize="1" noEditPoints="1" noAdjustHandles="1" noChangeArrowheads="1" noChangeShapeType="1" noTextEdit="1"/>
+              </p:cNvSpPr>
+              <p:nvPr/>
+            </p:nvSpPr>
+            <p:spPr>
+              <a:xfrm>
+                <a:off x="7607808" y="2548223"/>
+                <a:ext cx="1645920" cy="591124"/>
+              </a:xfrm>
+              <a:prstGeom prst="rect">
+                <a:avLst/>
+              </a:prstGeom>
+              <a:blipFill>
+                <a:blip r:embed="rId2"/>
+                <a:stretch>
+                  <a:fillRect t="-3093" b="-5155"/>
+                </a:stretch>
+              </a:blipFill>
+            </p:spPr>
+            <p:txBody>
+              <a:bodyPr/>
+              <a:lstStyle/>
+              <a:p>
+                <a:r>
+                  <a:rPr lang="en-US">
+                    <a:noFill/>
+                  </a:rPr>
+                  <a:t> </a:t>
+                </a:r>
+              </a:p>
+            </p:txBody>
+          </p:sp>
+        </mc:Fallback>
+      </mc:AlternateContent>
       <p:cxnSp>
         <p:nvCxnSpPr>
           <p:cNvPr id="21" name="Connector 20">
@@ -12783,41 +13354,6 @@
       </p:sp>
       <p:sp>
         <p:nvSpPr>
-          <p:cNvPr id="9" name="TextBox 8"/>
-          <p:cNvSpPr txBox="1"/>
-          <p:nvPr/>
-        </p:nvSpPr>
-        <p:spPr>
-          <a:xfrm>
-            <a:off x="1170432" y="3035808"/>
-            <a:ext cx="2596896" cy="804672"/>
-          </a:xfrm>
-          <a:prstGeom prst="rect">
-            <a:avLst/>
-          </a:prstGeom>
-          <a:noFill/>
-        </p:spPr>
-        <p:txBody>
-          <a:bodyPr wrap="square" lIns="45720" rIns="45720" anchor="t">
-            <a:spAutoFit/>
-          </a:bodyPr>
-          <a:lstStyle/>
-          <a:p>
-            <a:pPr algn="l"/>
-            <a:r>
-              <a:rPr sz="1300" b="0">
-                <a:solidFill>
-                  <a:srgbClr val="53616E"/>
-                </a:solidFill>
-                <a:latin typeface="Aptos"/>
-              </a:rPr>
-              <a:t>z=0.5 and z=0.9</a:t>
-            </a:r>
-          </a:p>
-        </p:txBody>
-      </p:sp>
-      <p:sp>
-        <p:nvSpPr>
           <p:cNvPr id="10" name="Rounded Rectangle 9"/>
           <p:cNvSpPr/>
           <p:nvPr/>
@@ -12899,41 +13435,6 @@
       </p:sp>
       <p:sp>
         <p:nvSpPr>
-          <p:cNvPr id="12" name="TextBox 11"/>
-          <p:cNvSpPr txBox="1"/>
-          <p:nvPr/>
-        </p:nvSpPr>
-        <p:spPr>
-          <a:xfrm>
-            <a:off x="4782312" y="3035808"/>
-            <a:ext cx="2596896" cy="804672"/>
-          </a:xfrm>
-          <a:prstGeom prst="rect">
-            <a:avLst/>
-          </a:prstGeom>
-          <a:noFill/>
-        </p:spPr>
-        <p:txBody>
-          <a:bodyPr wrap="square" lIns="45720" rIns="45720" anchor="t">
-            <a:spAutoFit/>
-          </a:bodyPr>
-          <a:lstStyle/>
-          <a:p>
-            <a:pPr algn="l"/>
-            <a:r>
-              <a:rPr sz="1300" b="0">
-                <a:solidFill>
-                  <a:srgbClr val="53616E"/>
-                </a:solidFill>
-                <a:latin typeface="Aptos"/>
-              </a:rPr>
-              <a:t>|z|&gt;0.9</a:t>
-            </a:r>
-          </a:p>
-        </p:txBody>
-      </p:sp>
-      <p:sp>
-        <p:nvSpPr>
           <p:cNvPr id="13" name="Rounded Rectangle 12"/>
           <p:cNvSpPr/>
           <p:nvPr/>
@@ -13015,41 +13516,6 @@
       </p:sp>
       <p:sp>
         <p:nvSpPr>
-          <p:cNvPr id="15" name="TextBox 14"/>
-          <p:cNvSpPr txBox="1"/>
-          <p:nvPr/>
-        </p:nvSpPr>
-        <p:spPr>
-          <a:xfrm>
-            <a:off x="8394192" y="3035808"/>
-            <a:ext cx="2596896" cy="804672"/>
-          </a:xfrm>
-          <a:prstGeom prst="rect">
-            <a:avLst/>
-          </a:prstGeom>
-          <a:noFill/>
-        </p:spPr>
-        <p:txBody>
-          <a:bodyPr wrap="square" lIns="45720" rIns="45720" anchor="t">
-            <a:spAutoFit/>
-          </a:bodyPr>
-          <a:lstStyle/>
-          <a:p>
-            <a:pPr algn="l"/>
-            <a:r>
-              <a:rPr sz="1300" b="0">
-                <a:solidFill>
-                  <a:srgbClr val="53616E"/>
-                </a:solidFill>
-                <a:latin typeface="Aptos"/>
-              </a:rPr>
-              <a:t>Yes: the unit circle is in |z|&gt;0.9</a:t>
-            </a:r>
-          </a:p>
-        </p:txBody>
-      </p:sp>
-      <p:sp>
-        <p:nvSpPr>
           <p:cNvPr id="16" name="Rounded Rectangle 15"/>
           <p:cNvSpPr/>
           <p:nvPr/>
@@ -13200,6 +13666,835 @@
         </p:txBody>
       </p:sp>
     </p:spTree>
+  </p:cSld>
+  <p:clrMapOvr>
+    <a:masterClrMapping/>
+  </p:clrMapOvr>
+</p:sld>
+</file>
+
+<file path=ppt/slides/slide28.xml><?xml version="1.0" encoding="utf-8"?>
+<p:sld xmlns:a="http://schemas.openxmlformats.org/drawingml/2006/main" xmlns:r="http://schemas.openxmlformats.org/officeDocument/2006/relationships" xmlns:p="http://schemas.openxmlformats.org/presentationml/2006/main">
+  <p:cSld>
+    <p:spTree>
+      <p:nvGrpSpPr>
+        <p:cNvPr id="1" name="">
+          <a:extLst>
+            <a:ext uri="{FF2B5EF4-FFF2-40B4-BE49-F238E27FC236}">
+              <a16:creationId xmlns:a16="http://schemas.microsoft.com/office/drawing/2014/main" id="{8902FCE5-61CB-FF44-BC4B-9BA1D97B3A24}"/>
+            </a:ext>
+          </a:extLst>
+        </p:cNvPr>
+        <p:cNvGrpSpPr/>
+        <p:nvPr/>
+      </p:nvGrpSpPr>
+      <p:grpSpPr>
+        <a:xfrm>
+          <a:off x="0" y="0"/>
+          <a:ext cx="0" cy="0"/>
+          <a:chOff x="0" y="0"/>
+          <a:chExt cx="0" cy="0"/>
+        </a:xfrm>
+      </p:grpSpPr>
+      <p:sp>
+        <p:nvSpPr>
+          <p:cNvPr id="2" name="TextBox 1">
+            <a:extLst>
+              <a:ext uri="{FF2B5EF4-FFF2-40B4-BE49-F238E27FC236}">
+                <a16:creationId xmlns:a16="http://schemas.microsoft.com/office/drawing/2014/main" id="{03A2A268-EA70-C554-F664-86AB715D2DCE}"/>
+              </a:ext>
+            </a:extLst>
+          </p:cNvPr>
+          <p:cNvSpPr txBox="1"/>
+          <p:nvPr/>
+        </p:nvSpPr>
+        <p:spPr>
+          <a:xfrm>
+            <a:off x="566928" y="301752"/>
+            <a:ext cx="9692640" cy="438912"/>
+          </a:xfrm>
+          <a:prstGeom prst="rect">
+            <a:avLst/>
+          </a:prstGeom>
+          <a:noFill/>
+        </p:spPr>
+        <p:txBody>
+          <a:bodyPr wrap="square" lIns="45720" rIns="45720" anchor="ctr">
+            <a:spAutoFit/>
+          </a:bodyPr>
+          <a:lstStyle/>
+          <a:p>
+            <a:pPr algn="l"/>
+            <a:r>
+              <a:rPr sz="2400" b="1">
+                <a:solidFill>
+                  <a:srgbClr val="16324F"/>
+                </a:solidFill>
+                <a:latin typeface="Aptos"/>
+              </a:rPr>
+              <a:t>Board reserve: coefficient ↔ root sanity checks</a:t>
+            </a:r>
+          </a:p>
+        </p:txBody>
+      </p:sp>
+      <p:sp>
+        <p:nvSpPr>
+          <p:cNvPr id="3" name="Rounded Rectangle 2">
+            <a:extLst>
+              <a:ext uri="{FF2B5EF4-FFF2-40B4-BE49-F238E27FC236}">
+                <a16:creationId xmlns:a16="http://schemas.microsoft.com/office/drawing/2014/main" id="{3DC9B08C-2414-8B38-327E-C24D11FE2495}"/>
+              </a:ext>
+            </a:extLst>
+          </p:cNvPr>
+          <p:cNvSpPr/>
+          <p:nvPr/>
+        </p:nvSpPr>
+        <p:spPr>
+          <a:xfrm>
+            <a:off x="10332720" y="283464"/>
+            <a:ext cx="1234440" cy="347472"/>
+          </a:xfrm>
+          <a:prstGeom prst="roundRect">
+            <a:avLst/>
+          </a:prstGeom>
+          <a:solidFill>
+            <a:srgbClr val="E8F7F7"/>
+          </a:solidFill>
+          <a:ln w="12700">
+            <a:solidFill>
+              <a:srgbClr val="00A6A6"/>
+            </a:solidFill>
+          </a:ln>
+        </p:spPr>
+        <p:style>
+          <a:lnRef idx="1">
+            <a:schemeClr val="accent1"/>
+          </a:lnRef>
+          <a:fillRef idx="3">
+            <a:schemeClr val="accent1"/>
+          </a:fillRef>
+          <a:effectRef idx="2">
+            <a:schemeClr val="accent1"/>
+          </a:effectRef>
+          <a:fontRef idx="minor">
+            <a:schemeClr val="lt1"/>
+          </a:fontRef>
+        </p:style>
+        <p:txBody>
+          <a:bodyPr rtlCol="0" anchor="ctr"/>
+          <a:lstStyle/>
+          <a:p>
+            <a:pPr algn="ctr"/>
+            <a:endParaRPr/>
+          </a:p>
+        </p:txBody>
+      </p:sp>
+      <p:sp>
+        <p:nvSpPr>
+          <p:cNvPr id="4" name="TextBox 3">
+            <a:extLst>
+              <a:ext uri="{FF2B5EF4-FFF2-40B4-BE49-F238E27FC236}">
+                <a16:creationId xmlns:a16="http://schemas.microsoft.com/office/drawing/2014/main" id="{172A81A7-6CDF-8DE7-0DA0-DE2AF3B516FC}"/>
+              </a:ext>
+            </a:extLst>
+          </p:cNvPr>
+          <p:cNvSpPr txBox="1"/>
+          <p:nvPr/>
+        </p:nvSpPr>
+        <p:spPr>
+          <a:xfrm>
+            <a:off x="10351008" y="292608"/>
+            <a:ext cx="1197864" cy="310896"/>
+          </a:xfrm>
+          <a:prstGeom prst="rect">
+            <a:avLst/>
+          </a:prstGeom>
+          <a:noFill/>
+        </p:spPr>
+        <p:txBody>
+          <a:bodyPr wrap="square" lIns="45720" rIns="45720" anchor="ctr">
+            <a:spAutoFit/>
+          </a:bodyPr>
+          <a:lstStyle/>
+          <a:p>
+            <a:pPr algn="ctr"/>
+            <a:r>
+              <a:rPr sz="1100" b="1">
+                <a:solidFill>
+                  <a:srgbClr val="16324F"/>
+                </a:solidFill>
+                <a:latin typeface="Aptos"/>
+              </a:rPr>
+              <a:t>RESERVE</a:t>
+            </a:r>
+          </a:p>
+        </p:txBody>
+      </p:sp>
+      <p:sp>
+        <p:nvSpPr>
+          <p:cNvPr id="5" name="TextBox 4">
+            <a:extLst>
+              <a:ext uri="{FF2B5EF4-FFF2-40B4-BE49-F238E27FC236}">
+                <a16:creationId xmlns:a16="http://schemas.microsoft.com/office/drawing/2014/main" id="{FCAB49B7-CFDB-3DDA-6D70-C770D7AE467B}"/>
+              </a:ext>
+            </a:extLst>
+          </p:cNvPr>
+          <p:cNvSpPr txBox="1"/>
+          <p:nvPr/>
+        </p:nvSpPr>
+        <p:spPr>
+          <a:xfrm>
+            <a:off x="594360" y="786384"/>
+            <a:ext cx="10652760" cy="329184"/>
+          </a:xfrm>
+          <a:prstGeom prst="rect">
+            <a:avLst/>
+          </a:prstGeom>
+          <a:noFill/>
+        </p:spPr>
+        <p:txBody>
+          <a:bodyPr wrap="square" lIns="45720" rIns="45720" anchor="ctr">
+            <a:spAutoFit/>
+          </a:bodyPr>
+          <a:lstStyle/>
+          <a:p>
+            <a:pPr algn="l"/>
+            <a:r>
+              <a:rPr sz="1200" b="0">
+                <a:solidFill>
+                  <a:srgbClr val="53616E"/>
+                </a:solidFill>
+                <a:latin typeface="Aptos"/>
+              </a:rPr>
+              <a:t>Useful when students get lost in z⁻¹ polynomial conventions.</a:t>
+            </a:r>
+          </a:p>
+        </p:txBody>
+      </p:sp>
+      <p:sp>
+        <p:nvSpPr>
+          <p:cNvPr id="6" name="TextBox 5">
+            <a:extLst>
+              <a:ext uri="{FF2B5EF4-FFF2-40B4-BE49-F238E27FC236}">
+                <a16:creationId xmlns:a16="http://schemas.microsoft.com/office/drawing/2014/main" id="{FBEF1D03-9527-41A9-3273-91DFD517C8FE}"/>
+              </a:ext>
+            </a:extLst>
+          </p:cNvPr>
+          <p:cNvSpPr txBox="1"/>
+          <p:nvPr/>
+        </p:nvSpPr>
+        <p:spPr>
+          <a:xfrm>
+            <a:off x="914400" y="1417320"/>
+            <a:ext cx="10241280" cy="594360"/>
+          </a:xfrm>
+          <a:prstGeom prst="rect">
+            <a:avLst/>
+          </a:prstGeom>
+          <a:noFill/>
+        </p:spPr>
+        <p:txBody>
+          <a:bodyPr wrap="square" lIns="45720" rIns="45720" anchor="ctr">
+            <a:spAutoFit/>
+          </a:bodyPr>
+          <a:lstStyle/>
+          <a:p>
+            <a:pPr algn="ctr"/>
+            <a:r>
+              <a:rPr sz="2300" b="1">
+                <a:solidFill>
+                  <a:srgbClr val="16324F"/>
+                </a:solidFill>
+                <a:latin typeface="Aptos"/>
+              </a:rPr>
+              <a:t>1 − 1.4z⁻¹ + 0.45z⁻² = (1 − 0.5z⁻¹)(1 − 0.9z⁻¹)</a:t>
+            </a:r>
+          </a:p>
+        </p:txBody>
+      </p:sp>
+      <p:sp>
+        <p:nvSpPr>
+          <p:cNvPr id="7" name="Rounded Rectangle 6">
+            <a:extLst>
+              <a:ext uri="{FF2B5EF4-FFF2-40B4-BE49-F238E27FC236}">
+                <a16:creationId xmlns:a16="http://schemas.microsoft.com/office/drawing/2014/main" id="{CD710BDF-C327-4F57-FB59-BE20E7ACC0E3}"/>
+              </a:ext>
+            </a:extLst>
+          </p:cNvPr>
+          <p:cNvSpPr/>
+          <p:nvPr/>
+        </p:nvSpPr>
+        <p:spPr>
+          <a:xfrm>
+            <a:off x="1005840" y="2560320"/>
+            <a:ext cx="2926080" cy="1371600"/>
+          </a:xfrm>
+          <a:prstGeom prst="roundRect">
+            <a:avLst/>
+          </a:prstGeom>
+          <a:solidFill>
+            <a:srgbClr val="E8F7F7"/>
+          </a:solidFill>
+          <a:ln w="12700">
+            <a:solidFill>
+              <a:srgbClr val="00A6A6"/>
+            </a:solidFill>
+          </a:ln>
+        </p:spPr>
+        <p:style>
+          <a:lnRef idx="1">
+            <a:schemeClr val="accent1"/>
+          </a:lnRef>
+          <a:fillRef idx="3">
+            <a:schemeClr val="accent1"/>
+          </a:fillRef>
+          <a:effectRef idx="2">
+            <a:schemeClr val="accent1"/>
+          </a:effectRef>
+          <a:fontRef idx="minor">
+            <a:schemeClr val="lt1"/>
+          </a:fontRef>
+        </p:style>
+        <p:txBody>
+          <a:bodyPr rtlCol="0" anchor="ctr"/>
+          <a:lstStyle/>
+          <a:p>
+            <a:pPr algn="ctr"/>
+            <a:endParaRPr/>
+          </a:p>
+        </p:txBody>
+      </p:sp>
+      <p:sp>
+        <p:nvSpPr>
+          <p:cNvPr id="8" name="TextBox 7">
+            <a:extLst>
+              <a:ext uri="{FF2B5EF4-FFF2-40B4-BE49-F238E27FC236}">
+                <a16:creationId xmlns:a16="http://schemas.microsoft.com/office/drawing/2014/main" id="{6B576223-294F-D596-44F8-3F0D32A1B84F}"/>
+              </a:ext>
+            </a:extLst>
+          </p:cNvPr>
+          <p:cNvSpPr txBox="1"/>
+          <p:nvPr/>
+        </p:nvSpPr>
+        <p:spPr>
+          <a:xfrm>
+            <a:off x="1170432" y="2670048"/>
+            <a:ext cx="2596896" cy="320040"/>
+          </a:xfrm>
+          <a:prstGeom prst="rect">
+            <a:avLst/>
+          </a:prstGeom>
+          <a:noFill/>
+        </p:spPr>
+        <p:txBody>
+          <a:bodyPr wrap="square" lIns="45720" rIns="45720" anchor="ctr">
+            <a:spAutoFit/>
+          </a:bodyPr>
+          <a:lstStyle/>
+          <a:p>
+            <a:pPr algn="l"/>
+            <a:r>
+              <a:rPr sz="1500" b="1">
+                <a:solidFill>
+                  <a:srgbClr val="16324F"/>
+                </a:solidFill>
+                <a:latin typeface="Aptos"/>
+              </a:rPr>
+              <a:t>Poles</a:t>
+            </a:r>
+          </a:p>
+        </p:txBody>
+      </p:sp>
+      <p:sp>
+        <p:nvSpPr>
+          <p:cNvPr id="9" name="TextBox 8">
+            <a:extLst>
+              <a:ext uri="{FF2B5EF4-FFF2-40B4-BE49-F238E27FC236}">
+                <a16:creationId xmlns:a16="http://schemas.microsoft.com/office/drawing/2014/main" id="{6BBB541D-D95B-58F9-926D-1D36F7086230}"/>
+              </a:ext>
+            </a:extLst>
+          </p:cNvPr>
+          <p:cNvSpPr txBox="1"/>
+          <p:nvPr/>
+        </p:nvSpPr>
+        <p:spPr>
+          <a:xfrm>
+            <a:off x="1170432" y="3035808"/>
+            <a:ext cx="2596896" cy="804672"/>
+          </a:xfrm>
+          <a:prstGeom prst="rect">
+            <a:avLst/>
+          </a:prstGeom>
+          <a:noFill/>
+        </p:spPr>
+        <p:txBody>
+          <a:bodyPr wrap="square" lIns="45720" rIns="45720" anchor="t">
+            <a:spAutoFit/>
+          </a:bodyPr>
+          <a:lstStyle/>
+          <a:p>
+            <a:pPr algn="l"/>
+            <a:r>
+              <a:rPr sz="1300" b="0">
+                <a:solidFill>
+                  <a:srgbClr val="53616E"/>
+                </a:solidFill>
+                <a:latin typeface="Aptos"/>
+              </a:rPr>
+              <a:t>z=0.5 and z=0.9</a:t>
+            </a:r>
+          </a:p>
+        </p:txBody>
+      </p:sp>
+      <p:sp>
+        <p:nvSpPr>
+          <p:cNvPr id="10" name="Rounded Rectangle 9">
+            <a:extLst>
+              <a:ext uri="{FF2B5EF4-FFF2-40B4-BE49-F238E27FC236}">
+                <a16:creationId xmlns:a16="http://schemas.microsoft.com/office/drawing/2014/main" id="{A87B9246-3811-2D1B-6E71-6746EF3C23C9}"/>
+              </a:ext>
+            </a:extLst>
+          </p:cNvPr>
+          <p:cNvSpPr/>
+          <p:nvPr/>
+        </p:nvSpPr>
+        <p:spPr>
+          <a:xfrm>
+            <a:off x="4617720" y="2560320"/>
+            <a:ext cx="2926080" cy="1371600"/>
+          </a:xfrm>
+          <a:prstGeom prst="roundRect">
+            <a:avLst/>
+          </a:prstGeom>
+          <a:solidFill>
+            <a:srgbClr val="EDF3F7"/>
+          </a:solidFill>
+          <a:ln w="12700">
+            <a:solidFill>
+              <a:srgbClr val="DCE6EC"/>
+            </a:solidFill>
+          </a:ln>
+        </p:spPr>
+        <p:style>
+          <a:lnRef idx="1">
+            <a:schemeClr val="accent1"/>
+          </a:lnRef>
+          <a:fillRef idx="3">
+            <a:schemeClr val="accent1"/>
+          </a:fillRef>
+          <a:effectRef idx="2">
+            <a:schemeClr val="accent1"/>
+          </a:effectRef>
+          <a:fontRef idx="minor">
+            <a:schemeClr val="lt1"/>
+          </a:fontRef>
+        </p:style>
+        <p:txBody>
+          <a:bodyPr rtlCol="0" anchor="ctr"/>
+          <a:lstStyle/>
+          <a:p>
+            <a:pPr algn="ctr"/>
+            <a:endParaRPr/>
+          </a:p>
+        </p:txBody>
+      </p:sp>
+      <p:sp>
+        <p:nvSpPr>
+          <p:cNvPr id="11" name="TextBox 10">
+            <a:extLst>
+              <a:ext uri="{FF2B5EF4-FFF2-40B4-BE49-F238E27FC236}">
+                <a16:creationId xmlns:a16="http://schemas.microsoft.com/office/drawing/2014/main" id="{DAED8F2A-03DE-19B8-24CF-D720B3E46E25}"/>
+              </a:ext>
+            </a:extLst>
+          </p:cNvPr>
+          <p:cNvSpPr txBox="1"/>
+          <p:nvPr/>
+        </p:nvSpPr>
+        <p:spPr>
+          <a:xfrm>
+            <a:off x="4782312" y="2670048"/>
+            <a:ext cx="2596896" cy="320040"/>
+          </a:xfrm>
+          <a:prstGeom prst="rect">
+            <a:avLst/>
+          </a:prstGeom>
+          <a:noFill/>
+        </p:spPr>
+        <p:txBody>
+          <a:bodyPr wrap="square" lIns="45720" rIns="45720" anchor="ctr">
+            <a:spAutoFit/>
+          </a:bodyPr>
+          <a:lstStyle/>
+          <a:p>
+            <a:pPr algn="l"/>
+            <a:r>
+              <a:rPr sz="1500" b="1">
+                <a:solidFill>
+                  <a:srgbClr val="16324F"/>
+                </a:solidFill>
+                <a:latin typeface="Aptos"/>
+              </a:rPr>
+              <a:t>Causal ROC</a:t>
+            </a:r>
+          </a:p>
+        </p:txBody>
+      </p:sp>
+      <p:sp>
+        <p:nvSpPr>
+          <p:cNvPr id="12" name="TextBox 11">
+            <a:extLst>
+              <a:ext uri="{FF2B5EF4-FFF2-40B4-BE49-F238E27FC236}">
+                <a16:creationId xmlns:a16="http://schemas.microsoft.com/office/drawing/2014/main" id="{864B35DC-2714-1A55-DC6A-D1F1DC5A5E54}"/>
+              </a:ext>
+            </a:extLst>
+          </p:cNvPr>
+          <p:cNvSpPr txBox="1"/>
+          <p:nvPr/>
+        </p:nvSpPr>
+        <p:spPr>
+          <a:xfrm>
+            <a:off x="4782312" y="3035808"/>
+            <a:ext cx="2596896" cy="804672"/>
+          </a:xfrm>
+          <a:prstGeom prst="rect">
+            <a:avLst/>
+          </a:prstGeom>
+          <a:noFill/>
+        </p:spPr>
+        <p:txBody>
+          <a:bodyPr wrap="square" lIns="45720" rIns="45720" anchor="t">
+            <a:spAutoFit/>
+          </a:bodyPr>
+          <a:lstStyle/>
+          <a:p>
+            <a:pPr algn="l"/>
+            <a:r>
+              <a:rPr sz="1300" b="0">
+                <a:solidFill>
+                  <a:srgbClr val="53616E"/>
+                </a:solidFill>
+                <a:latin typeface="Aptos"/>
+              </a:rPr>
+              <a:t>|z|&gt;0.9</a:t>
+            </a:r>
+          </a:p>
+        </p:txBody>
+      </p:sp>
+      <p:sp>
+        <p:nvSpPr>
+          <p:cNvPr id="13" name="Rounded Rectangle 12">
+            <a:extLst>
+              <a:ext uri="{FF2B5EF4-FFF2-40B4-BE49-F238E27FC236}">
+                <a16:creationId xmlns:a16="http://schemas.microsoft.com/office/drawing/2014/main" id="{433F5A92-E8C8-D583-1FC8-35467A7924DC}"/>
+              </a:ext>
+            </a:extLst>
+          </p:cNvPr>
+          <p:cNvSpPr/>
+          <p:nvPr/>
+        </p:nvSpPr>
+        <p:spPr>
+          <a:xfrm>
+            <a:off x="8229600" y="2560320"/>
+            <a:ext cx="2926080" cy="1371600"/>
+          </a:xfrm>
+          <a:prstGeom prst="roundRect">
+            <a:avLst/>
+          </a:prstGeom>
+          <a:solidFill>
+            <a:srgbClr val="FFF2E6"/>
+          </a:solidFill>
+          <a:ln w="12700">
+            <a:solidFill>
+              <a:srgbClr val="F28E2B"/>
+            </a:solidFill>
+          </a:ln>
+        </p:spPr>
+        <p:style>
+          <a:lnRef idx="1">
+            <a:schemeClr val="accent1"/>
+          </a:lnRef>
+          <a:fillRef idx="3">
+            <a:schemeClr val="accent1"/>
+          </a:fillRef>
+          <a:effectRef idx="2">
+            <a:schemeClr val="accent1"/>
+          </a:effectRef>
+          <a:fontRef idx="minor">
+            <a:schemeClr val="lt1"/>
+          </a:fontRef>
+        </p:style>
+        <p:txBody>
+          <a:bodyPr rtlCol="0" anchor="ctr"/>
+          <a:lstStyle/>
+          <a:p>
+            <a:pPr algn="ctr"/>
+            <a:endParaRPr/>
+          </a:p>
+        </p:txBody>
+      </p:sp>
+      <p:sp>
+        <p:nvSpPr>
+          <p:cNvPr id="14" name="TextBox 13">
+            <a:extLst>
+              <a:ext uri="{FF2B5EF4-FFF2-40B4-BE49-F238E27FC236}">
+                <a16:creationId xmlns:a16="http://schemas.microsoft.com/office/drawing/2014/main" id="{0C3F0D50-3D58-D98A-61F2-8BE943C506F6}"/>
+              </a:ext>
+            </a:extLst>
+          </p:cNvPr>
+          <p:cNvSpPr txBox="1"/>
+          <p:nvPr/>
+        </p:nvSpPr>
+        <p:spPr>
+          <a:xfrm>
+            <a:off x="8394192" y="2670048"/>
+            <a:ext cx="2596896" cy="320040"/>
+          </a:xfrm>
+          <a:prstGeom prst="rect">
+            <a:avLst/>
+          </a:prstGeom>
+          <a:noFill/>
+        </p:spPr>
+        <p:txBody>
+          <a:bodyPr wrap="square" lIns="45720" rIns="45720" anchor="ctr">
+            <a:spAutoFit/>
+          </a:bodyPr>
+          <a:lstStyle/>
+          <a:p>
+            <a:pPr algn="l"/>
+            <a:r>
+              <a:rPr sz="1500" b="1">
+                <a:solidFill>
+                  <a:srgbClr val="16324F"/>
+                </a:solidFill>
+                <a:latin typeface="Aptos"/>
+              </a:rPr>
+              <a:t>Stable?</a:t>
+            </a:r>
+          </a:p>
+        </p:txBody>
+      </p:sp>
+      <p:sp>
+        <p:nvSpPr>
+          <p:cNvPr id="15" name="TextBox 14">
+            <a:extLst>
+              <a:ext uri="{FF2B5EF4-FFF2-40B4-BE49-F238E27FC236}">
+                <a16:creationId xmlns:a16="http://schemas.microsoft.com/office/drawing/2014/main" id="{3A8C145B-345C-954F-9728-A30107944F37}"/>
+              </a:ext>
+            </a:extLst>
+          </p:cNvPr>
+          <p:cNvSpPr txBox="1"/>
+          <p:nvPr/>
+        </p:nvSpPr>
+        <p:spPr>
+          <a:xfrm>
+            <a:off x="8394192" y="3035808"/>
+            <a:ext cx="2596896" cy="804672"/>
+          </a:xfrm>
+          <a:prstGeom prst="rect">
+            <a:avLst/>
+          </a:prstGeom>
+          <a:noFill/>
+        </p:spPr>
+        <p:txBody>
+          <a:bodyPr wrap="square" lIns="45720" rIns="45720" anchor="t">
+            <a:spAutoFit/>
+          </a:bodyPr>
+          <a:lstStyle/>
+          <a:p>
+            <a:pPr algn="l"/>
+            <a:r>
+              <a:rPr sz="1300" b="0">
+                <a:solidFill>
+                  <a:srgbClr val="53616E"/>
+                </a:solidFill>
+                <a:latin typeface="Aptos"/>
+              </a:rPr>
+              <a:t>Yes: the unit circle is in |z|&gt;0.9</a:t>
+            </a:r>
+          </a:p>
+        </p:txBody>
+      </p:sp>
+      <p:sp>
+        <p:nvSpPr>
+          <p:cNvPr id="16" name="Rounded Rectangle 15">
+            <a:extLst>
+              <a:ext uri="{FF2B5EF4-FFF2-40B4-BE49-F238E27FC236}">
+                <a16:creationId xmlns:a16="http://schemas.microsoft.com/office/drawing/2014/main" id="{5C6F2595-9229-3ED5-D0AC-B6485CAA33EC}"/>
+              </a:ext>
+            </a:extLst>
+          </p:cNvPr>
+          <p:cNvSpPr/>
+          <p:nvPr/>
+        </p:nvSpPr>
+        <p:spPr>
+          <a:xfrm>
+            <a:off x="1143000" y="4572000"/>
+            <a:ext cx="9875520" cy="822960"/>
+          </a:xfrm>
+          <a:prstGeom prst="roundRect">
+            <a:avLst/>
+          </a:prstGeom>
+          <a:solidFill>
+            <a:srgbClr val="FFFFFF"/>
+          </a:solidFill>
+          <a:ln w="12700">
+            <a:solidFill>
+              <a:srgbClr val="DCE6EC"/>
+            </a:solidFill>
+          </a:ln>
+        </p:spPr>
+        <p:style>
+          <a:lnRef idx="1">
+            <a:schemeClr val="accent1"/>
+          </a:lnRef>
+          <a:fillRef idx="3">
+            <a:schemeClr val="accent1"/>
+          </a:fillRef>
+          <a:effectRef idx="2">
+            <a:schemeClr val="accent1"/>
+          </a:effectRef>
+          <a:fontRef idx="minor">
+            <a:schemeClr val="lt1"/>
+          </a:fontRef>
+        </p:style>
+        <p:txBody>
+          <a:bodyPr rtlCol="0" anchor="ctr"/>
+          <a:lstStyle/>
+          <a:p>
+            <a:pPr algn="ctr"/>
+            <a:endParaRPr/>
+          </a:p>
+        </p:txBody>
+      </p:sp>
+      <p:sp>
+        <p:nvSpPr>
+          <p:cNvPr id="17" name="TextBox 16">
+            <a:extLst>
+              <a:ext uri="{FF2B5EF4-FFF2-40B4-BE49-F238E27FC236}">
+                <a16:creationId xmlns:a16="http://schemas.microsoft.com/office/drawing/2014/main" id="{AEEFE951-BEE1-991C-F54B-2578F28FCA6E}"/>
+              </a:ext>
+            </a:extLst>
+          </p:cNvPr>
+          <p:cNvSpPr txBox="1"/>
+          <p:nvPr/>
+        </p:nvSpPr>
+        <p:spPr>
+          <a:xfrm>
+            <a:off x="1371600" y="4754880"/>
+            <a:ext cx="9418320" cy="457200"/>
+          </a:xfrm>
+          <a:prstGeom prst="rect">
+            <a:avLst/>
+          </a:prstGeom>
+          <a:noFill/>
+        </p:spPr>
+        <p:txBody>
+          <a:bodyPr wrap="square" lIns="45720" rIns="45720" anchor="ctr">
+            <a:spAutoFit/>
+          </a:bodyPr>
+          <a:lstStyle/>
+          <a:p>
+            <a:pPr algn="ctr"/>
+            <a:r>
+              <a:rPr sz="1700" b="1">
+                <a:solidFill>
+                  <a:srgbClr val="16324F"/>
+                </a:solidFill>
+                <a:latin typeface="Aptos"/>
+              </a:rPr>
+              <a:t>Fast check: for a causal rational system, if any pole magnitude ≥1, do not call it BIBO stable.</a:t>
+            </a:r>
+          </a:p>
+        </p:txBody>
+      </p:sp>
+      <p:sp>
+        <p:nvSpPr>
+          <p:cNvPr id="18" name="TextBox 17">
+            <a:extLst>
+              <a:ext uri="{FF2B5EF4-FFF2-40B4-BE49-F238E27FC236}">
+                <a16:creationId xmlns:a16="http://schemas.microsoft.com/office/drawing/2014/main" id="{9D48DF97-360E-02F6-1AC0-0A199CCC068B}"/>
+              </a:ext>
+            </a:extLst>
+          </p:cNvPr>
+          <p:cNvSpPr txBox="1"/>
+          <p:nvPr/>
+        </p:nvSpPr>
+        <p:spPr>
+          <a:xfrm>
+            <a:off x="566928" y="6473952"/>
+            <a:ext cx="4754880" cy="164592"/>
+          </a:xfrm>
+          <a:prstGeom prst="rect">
+            <a:avLst/>
+          </a:prstGeom>
+          <a:noFill/>
+        </p:spPr>
+        <p:txBody>
+          <a:bodyPr wrap="square" lIns="45720" rIns="45720" anchor="ctr">
+            <a:spAutoFit/>
+          </a:bodyPr>
+          <a:lstStyle/>
+          <a:p>
+            <a:pPr algn="l"/>
+            <a:r>
+              <a:rPr sz="800" b="0">
+                <a:solidFill>
+                  <a:srgbClr val="53616E"/>
+                </a:solidFill>
+                <a:latin typeface="Aptos"/>
+              </a:rPr>
+              <a:t>Week 3 • DSP + ML • Oppenheim &amp; Schafer</a:t>
+            </a:r>
+          </a:p>
+        </p:txBody>
+      </p:sp>
+      <p:sp>
+        <p:nvSpPr>
+          <p:cNvPr id="19" name="TextBox 18">
+            <a:extLst>
+              <a:ext uri="{FF2B5EF4-FFF2-40B4-BE49-F238E27FC236}">
+                <a16:creationId xmlns:a16="http://schemas.microsoft.com/office/drawing/2014/main" id="{8A202012-7C86-F35F-9B72-6063D9E54A43}"/>
+              </a:ext>
+            </a:extLst>
+          </p:cNvPr>
+          <p:cNvSpPr txBox="1"/>
+          <p:nvPr/>
+        </p:nvSpPr>
+        <p:spPr>
+          <a:xfrm>
+            <a:off x="11201400" y="6473952"/>
+            <a:ext cx="320040" cy="164592"/>
+          </a:xfrm>
+          <a:prstGeom prst="rect">
+            <a:avLst/>
+          </a:prstGeom>
+          <a:noFill/>
+        </p:spPr>
+        <p:txBody>
+          <a:bodyPr wrap="square" lIns="45720" rIns="45720" anchor="ctr">
+            <a:spAutoFit/>
+          </a:bodyPr>
+          <a:lstStyle/>
+          <a:p>
+            <a:pPr algn="r"/>
+            <a:r>
+              <a:rPr sz="800" b="0">
+                <a:solidFill>
+                  <a:srgbClr val="53616E"/>
+                </a:solidFill>
+                <a:latin typeface="Aptos"/>
+              </a:rPr>
+              <a:t>23</a:t>
+            </a:r>
+          </a:p>
+        </p:txBody>
+      </p:sp>
+    </p:spTree>
+    <p:extLst>
+      <p:ext uri="{BB962C8B-B14F-4D97-AF65-F5344CB8AC3E}">
+        <p14:creationId xmlns:p14="http://schemas.microsoft.com/office/powerpoint/2010/main" val="3896830179"/>
+      </p:ext>
+    </p:extLst>
   </p:cSld>
   <p:clrMapOvr>
     <a:masterClrMapping/>
@@ -15380,41 +16675,330 @@
           </a:p>
         </p:txBody>
       </p:sp>
-      <p:sp>
-        <p:nvSpPr>
-          <p:cNvPr id="9" name="TextBox 8"/>
-          <p:cNvSpPr txBox="1"/>
-          <p:nvPr/>
-        </p:nvSpPr>
-        <p:spPr>
-          <a:xfrm>
-            <a:off x="1188720" y="2926080"/>
-            <a:ext cx="4297680" cy="1097280"/>
-          </a:xfrm>
-          <a:prstGeom prst="rect">
-            <a:avLst/>
-          </a:prstGeom>
-          <a:noFill/>
-        </p:spPr>
-        <p:txBody>
-          <a:bodyPr wrap="square" lIns="45720" rIns="45720" anchor="ctr">
-            <a:spAutoFit/>
-          </a:bodyPr>
-          <a:lstStyle/>
-          <a:p>
-            <a:pPr algn="ctr"/>
-            <a:r>
-              <a:rPr sz="1700" b="0">
-                <a:solidFill>
-                  <a:srgbClr val="53616E"/>
-                </a:solidFill>
-                <a:latin typeface="Aptos"/>
-              </a:rPr>
-              <a:t>Then H(e^{jω}) = Σ h[n]e^{-jωn} converges for every ω.</a:t>
-            </a:r>
-          </a:p>
-        </p:txBody>
-      </p:sp>
+      <mc:AlternateContent xmlns:mc="http://schemas.openxmlformats.org/markup-compatibility/2006">
+        <mc:Choice xmlns:a14="http://schemas.microsoft.com/office/drawing/2010/main" Requires="a14">
+          <p:sp>
+            <p:nvSpPr>
+              <p:cNvPr id="9" name="TextBox 8"/>
+              <p:cNvSpPr txBox="1"/>
+              <p:nvPr/>
+            </p:nvSpPr>
+            <p:spPr>
+              <a:xfrm>
+                <a:off x="1188720" y="3156780"/>
+                <a:ext cx="4297680" cy="635880"/>
+              </a:xfrm>
+              <a:prstGeom prst="rect">
+                <a:avLst/>
+              </a:prstGeom>
+              <a:noFill/>
+            </p:spPr>
+            <p:txBody>
+              <a:bodyPr wrap="square" lIns="45720" rIns="45720" anchor="ctr">
+                <a:spAutoFit/>
+              </a:bodyPr>
+              <a:lstStyle/>
+              <a:p>
+                <a:pPr algn="ctr"/>
+                <a:r>
+                  <a:rPr lang="en-US" sz="1700" b="0" dirty="0">
+                    <a:solidFill>
+                      <a:srgbClr val="53616E"/>
+                    </a:solidFill>
+                    <a:latin typeface="Aptos"/>
+                  </a:rPr>
+                  <a:t>Then </a:t>
+                </a:r>
+                <a14:m>
+                  <m:oMath xmlns:m="http://schemas.openxmlformats.org/officeDocument/2006/math">
+                    <m:r>
+                      <a:rPr lang="en-US" sz="1700" b="0" i="1" dirty="0" smtClean="0">
+                        <a:solidFill>
+                          <a:srgbClr val="53616E"/>
+                        </a:solidFill>
+                        <a:latin typeface="Cambria Math" panose="02040503050406030204" pitchFamily="18" charset="0"/>
+                      </a:rPr>
+                      <m:t>𝐻</m:t>
+                    </m:r>
+                    <m:r>
+                      <a:rPr lang="en-US" sz="1700" b="0" i="1" dirty="0" smtClean="0">
+                        <a:solidFill>
+                          <a:srgbClr val="53616E"/>
+                        </a:solidFill>
+                        <a:latin typeface="Cambria Math" panose="02040503050406030204" pitchFamily="18" charset="0"/>
+                      </a:rPr>
+                      <m:t>(</m:t>
+                    </m:r>
+                    <m:sSup>
+                      <m:sSupPr>
+                        <m:ctrlPr>
+                          <a:rPr lang="ar-AE" sz="1700" b="0" i="1" dirty="0" smtClean="0">
+                            <a:solidFill>
+                              <a:srgbClr val="53616E"/>
+                            </a:solidFill>
+                            <a:latin typeface="Cambria Math" panose="02040503050406030204" pitchFamily="18" charset="0"/>
+                          </a:rPr>
+                        </m:ctrlPr>
+                      </m:sSupPr>
+                      <m:e>
+                        <m:r>
+                          <a:rPr lang="ar-AE" sz="1700" b="0" i="1" dirty="0" smtClean="0">
+                            <a:solidFill>
+                              <a:srgbClr val="53616E"/>
+                            </a:solidFill>
+                            <a:latin typeface="Cambria Math" panose="02040503050406030204" pitchFamily="18" charset="0"/>
+                          </a:rPr>
+                          <m:t>𝑒</m:t>
+                        </m:r>
+                      </m:e>
+                      <m:sup>
+                        <m:r>
+                          <a:rPr lang="ar-AE" sz="1700" b="0" i="1" dirty="0" err="1">
+                            <a:solidFill>
+                              <a:srgbClr val="53616E"/>
+                            </a:solidFill>
+                            <a:latin typeface="Cambria Math" panose="02040503050406030204" pitchFamily="18" charset="0"/>
+                          </a:rPr>
+                          <m:t>𝑗</m:t>
+                        </m:r>
+                        <m:r>
+                          <a:rPr lang="ar-AE" sz="1700" b="0" i="1" dirty="0" err="1">
+                            <a:solidFill>
+                              <a:srgbClr val="53616E"/>
+                            </a:solidFill>
+                            <a:latin typeface="Cambria Math" panose="02040503050406030204" pitchFamily="18" charset="0"/>
+                          </a:rPr>
+                          <m:t>𝜔</m:t>
+                        </m:r>
+                      </m:sup>
+                    </m:sSup>
+                    <m:r>
+                      <a:rPr lang="ar-AE" sz="1700" b="0" i="1" dirty="0">
+                        <a:solidFill>
+                          <a:srgbClr val="53616E"/>
+                        </a:solidFill>
+                        <a:latin typeface="Cambria Math" panose="02040503050406030204" pitchFamily="18" charset="0"/>
+                      </a:rPr>
+                      <m:t>) = </m:t>
+                    </m:r>
+                    <m:nary>
+                      <m:naryPr>
+                        <m:chr m:val="∑"/>
+                        <m:limLoc m:val="subSup"/>
+                        <m:supHide m:val="on"/>
+                        <m:ctrlPr>
+                          <a:rPr lang="en-US" sz="1700" b="0" i="1" dirty="0" smtClean="0">
+                            <a:solidFill>
+                              <a:srgbClr val="53616E"/>
+                            </a:solidFill>
+                            <a:latin typeface="Cambria Math" panose="02040503050406030204" pitchFamily="18" charset="0"/>
+                          </a:rPr>
+                        </m:ctrlPr>
+                      </m:naryPr>
+                      <m:sub>
+                        <m:r>
+                          <m:rPr>
+                            <m:brk m:alnAt="9"/>
+                          </m:rPr>
+                          <a:rPr lang="en-US" sz="1700" b="0" i="1" dirty="0" smtClean="0">
+                            <a:solidFill>
+                              <a:srgbClr val="53616E"/>
+                            </a:solidFill>
+                            <a:latin typeface="Cambria Math" panose="02040503050406030204" pitchFamily="18" charset="0"/>
+                          </a:rPr>
+                          <m:t>𝑛</m:t>
+                        </m:r>
+                      </m:sub>
+                      <m:sup/>
+                      <m:e>
+                        <m:r>
+                          <a:rPr lang="el-GR" sz="1700" i="1" dirty="0">
+                            <a:solidFill>
+                              <a:srgbClr val="53616E"/>
+                            </a:solidFill>
+                            <a:latin typeface="Cambria Math" panose="02040503050406030204" pitchFamily="18" charset="0"/>
+                          </a:rPr>
+                          <m:t>ℎ</m:t>
+                        </m:r>
+                        <m:d>
+                          <m:dPr>
+                            <m:begChr m:val="["/>
+                            <m:endChr m:val="]"/>
+                            <m:ctrlPr>
+                              <a:rPr lang="el-GR" sz="1700" i="1" dirty="0">
+                                <a:solidFill>
+                                  <a:srgbClr val="53616E"/>
+                                </a:solidFill>
+                                <a:latin typeface="Cambria Math" panose="02040503050406030204" pitchFamily="18" charset="0"/>
+                              </a:rPr>
+                            </m:ctrlPr>
+                          </m:dPr>
+                          <m:e>
+                            <m:r>
+                              <a:rPr lang="el-GR" sz="1700" i="1" dirty="0">
+                                <a:solidFill>
+                                  <a:srgbClr val="53616E"/>
+                                </a:solidFill>
+                                <a:latin typeface="Cambria Math" panose="02040503050406030204" pitchFamily="18" charset="0"/>
+                              </a:rPr>
+                              <m:t>𝑛</m:t>
+                            </m:r>
+                          </m:e>
+                        </m:d>
+                        <m:sSup>
+                          <m:sSupPr>
+                            <m:ctrlPr>
+                              <a:rPr lang="el-GR" sz="1700" i="1" dirty="0">
+                                <a:solidFill>
+                                  <a:srgbClr val="53616E"/>
+                                </a:solidFill>
+                                <a:latin typeface="Cambria Math" panose="02040503050406030204" pitchFamily="18" charset="0"/>
+                              </a:rPr>
+                            </m:ctrlPr>
+                          </m:sSupPr>
+                          <m:e>
+                            <m:r>
+                              <a:rPr lang="el-GR" sz="1700" i="1" dirty="0">
+                                <a:solidFill>
+                                  <a:srgbClr val="53616E"/>
+                                </a:solidFill>
+                                <a:latin typeface="Cambria Math" panose="02040503050406030204" pitchFamily="18" charset="0"/>
+                              </a:rPr>
+                              <m:t>𝑒</m:t>
+                            </m:r>
+                          </m:e>
+                          <m:sup>
+                            <m:r>
+                              <a:rPr lang="el-GR" sz="1700" i="1" dirty="0">
+                                <a:solidFill>
+                                  <a:srgbClr val="53616E"/>
+                                </a:solidFill>
+                                <a:latin typeface="Cambria Math" panose="02040503050406030204" pitchFamily="18" charset="0"/>
+                              </a:rPr>
+                              <m:t>−</m:t>
+                            </m:r>
+                            <m:r>
+                              <a:rPr lang="el-GR" sz="1700" i="1" dirty="0" err="1">
+                                <a:solidFill>
+                                  <a:srgbClr val="53616E"/>
+                                </a:solidFill>
+                                <a:latin typeface="Cambria Math" panose="02040503050406030204" pitchFamily="18" charset="0"/>
+                              </a:rPr>
+                              <m:t>𝑗</m:t>
+                            </m:r>
+                            <m:r>
+                              <a:rPr lang="el-GR" sz="1700" i="1" dirty="0" err="1">
+                                <a:solidFill>
+                                  <a:srgbClr val="53616E"/>
+                                </a:solidFill>
+                                <a:latin typeface="Cambria Math" panose="02040503050406030204" pitchFamily="18" charset="0"/>
+                              </a:rPr>
+                              <m:t>𝜔</m:t>
+                            </m:r>
+                            <m:r>
+                              <a:rPr lang="el-GR" sz="1700" i="1" dirty="0" err="1">
+                                <a:solidFill>
+                                  <a:srgbClr val="53616E"/>
+                                </a:solidFill>
+                                <a:latin typeface="Cambria Math" panose="02040503050406030204" pitchFamily="18" charset="0"/>
+                              </a:rPr>
+                              <m:t>𝑛</m:t>
+                            </m:r>
+                          </m:sup>
+                        </m:sSup>
+                      </m:e>
+                    </m:nary>
+                    <m:r>
+                      <a:rPr lang="el-GR" sz="1700" b="0" i="1" dirty="0">
+                        <a:solidFill>
+                          <a:srgbClr val="53616E"/>
+                        </a:solidFill>
+                        <a:latin typeface="Cambria Math" panose="02040503050406030204" pitchFamily="18" charset="0"/>
+                      </a:rPr>
+                      <m:t> </m:t>
+                    </m:r>
+                  </m:oMath>
+                </a14:m>
+                <a:r>
+                  <a:rPr lang="en-US" sz="1700" b="0" dirty="0">
+                    <a:solidFill>
+                      <a:srgbClr val="53616E"/>
+                    </a:solidFill>
+                    <a:latin typeface="Aptos"/>
+                  </a:rPr>
+                  <a:t>converges for every </a:t>
+                </a:r>
+                <a14:m>
+                  <m:oMath xmlns:m="http://schemas.openxmlformats.org/officeDocument/2006/math">
+                    <m:r>
+                      <a:rPr lang="el-GR" sz="1700" b="0" i="1" dirty="0" smtClean="0">
+                        <a:solidFill>
+                          <a:srgbClr val="53616E"/>
+                        </a:solidFill>
+                        <a:latin typeface="Cambria Math" panose="02040503050406030204" pitchFamily="18" charset="0"/>
+                      </a:rPr>
+                      <m:t>𝜔</m:t>
+                    </m:r>
+                  </m:oMath>
+                </a14:m>
+                <a:r>
+                  <a:rPr lang="el-GR" sz="1700" b="0" dirty="0">
+                    <a:solidFill>
+                      <a:srgbClr val="53616E"/>
+                    </a:solidFill>
+                    <a:latin typeface="Aptos"/>
+                  </a:rPr>
+                  <a:t>.</a:t>
+                </a:r>
+                <a:endParaRPr sz="1700" b="0" dirty="0">
+                  <a:solidFill>
+                    <a:srgbClr val="53616E"/>
+                  </a:solidFill>
+                  <a:latin typeface="Aptos"/>
+                </a:endParaRPr>
+              </a:p>
+            </p:txBody>
+          </p:sp>
+        </mc:Choice>
+        <mc:Fallback>
+          <p:sp>
+            <p:nvSpPr>
+              <p:cNvPr id="9" name="TextBox 8"/>
+              <p:cNvSpPr txBox="1">
+                <a:spLocks noRot="1" noChangeAspect="1" noMove="1" noResize="1" noEditPoints="1" noAdjustHandles="1" noChangeArrowheads="1" noChangeShapeType="1" noTextEdit="1"/>
+              </p:cNvSpPr>
+              <p:nvPr/>
+            </p:nvSpPr>
+            <p:spPr>
+              <a:xfrm>
+                <a:off x="1188720" y="3156780"/>
+                <a:ext cx="4297680" cy="635880"/>
+              </a:xfrm>
+              <a:prstGeom prst="rect">
+                <a:avLst/>
+              </a:prstGeom>
+              <a:blipFill>
+                <a:blip r:embed="rId2"/>
+                <a:stretch>
+                  <a:fillRect l="-709" t="-61538" r="-1560" b="-54808"/>
+                </a:stretch>
+              </a:blipFill>
+            </p:spPr>
+            <p:txBody>
+              <a:bodyPr/>
+              <a:lstStyle/>
+              <a:p>
+                <a:r>
+                  <a:rPr lang="en-US">
+                    <a:noFill/>
+                  </a:rPr>
+                  <a:t> </a:t>
+                </a:r>
+              </a:p>
+            </p:txBody>
+          </p:sp>
+        </mc:Fallback>
+      </mc:AlternateContent>
       <p:sp>
         <p:nvSpPr>
           <p:cNvPr id="10" name="Rounded Rectangle 9"/>

</xml_diff>